<commit_message>
docs: broaden target setting from transplant ICU to all ICUs (critical care broadly); advisory framing unchanged
</commit_message>
<xml_diff>
--- a/Cognitive-Companion-Presentation.pptx
+++ b/Cognitive-Companion-Presentation.pptx
@@ -3680,7 +3680,7 @@
                 <a:ea typeface="Calibri" pitchFamily="34" charset="-122"/>
                 <a:cs typeface="Calibri" pitchFamily="34" charset="-120"/>
               </a:rPr>
-              <a:t>Face-worn cameras in a transplant ICU are a PHI, consent, and culture problem.</a:t>
+              <a:t>Face-worn cameras in any ICU are a PHI, consent, and culture problem.</a:t>
             </a:r>
             <a:endParaRPr lang="en-US" sz="1400" dirty="0"/>
           </a:p>
@@ -7207,7 +7207,7 @@
                 <a:ea typeface="Calibri" pitchFamily="34" charset="-122"/>
                 <a:cs typeface="Calibri" pitchFamily="34" charset="-120"/>
               </a:rPr>
-              <a:t>A face-worn camera in a transplant ICU is a PHI + consent + culture problem — not just a tech feature. v1 senses with sound only.</a:t>
+              <a:t>A face-worn camera in any ICU is a PHI + consent + culture problem — not just a tech feature. v1 senses with sound only.</a:t>
             </a:r>
             <a:endParaRPr lang="en-US" sz="1500" dirty="0"/>
           </a:p>

</xml_diff>

<commit_message>
rebrand: replace Crisis Mirror with Cognitive Companion across docs and code
Sweep display names, slugs, GitHub paths, package metadata, research notes,
deck builder, and regenerated PPTX. Dossier story-so-far notes that Crisis Mirror
was the early working name; the project is now branded Cognitive Companion.
Repo renamed on GitHub to senrealinvestment/cognitive-companion.
</commit_message>
<xml_diff>
--- a/Cognitive-Companion-Presentation.pptx
+++ b/Cognitive-Companion-Presentation.pptx
@@ -2225,7 +2225,7 @@
                 <a:ea typeface="Calibri" pitchFamily="34" charset="-122"/>
                 <a:cs typeface="Calibri" pitchFamily="34" charset="-120"/>
               </a:rPr>
-              <a:t>Formerly Crisis Mirror  ·  July 2026</a:t>
+              <a:t>Cognitive Companion  ·  July 2026</a:t>
             </a:r>
             <a:endParaRPr lang="en-US" sz="1100" dirty="0"/>
           </a:p>
@@ -3110,7 +3110,7 @@
                 <a:ea typeface="Calibri" pitchFamily="34" charset="-122"/>
                 <a:cs typeface="Calibri" pitchFamily="34" charset="-120"/>
               </a:rPr>
-              <a:t>Advisory · camera-free · education first  ·  github.com/senrealinvestment/crisis-mirror</a:t>
+              <a:t>Advisory · camera-free · education first  ·  github.com/senrealinvestment/cognitive-companion</a:t>
             </a:r>
             <a:endParaRPr lang="en-US" sz="1100" dirty="0"/>
           </a:p>

</xml_diff>